<commit_message>
Enhance roadmap-pptx skill output: clear current progress (40%), next tasks details, visual bars in PPTX and MDs (2026-06-27)
</commit_message>
<xml_diff>
--- a/docs/roadmap-pptx/Korean_Bible_App_Roadmap_및_작업제안_2026-06-27.pptx
+++ b/docs/roadmap-pptx/Korean_Bible_App_Roadmap_및_작업제안_2026-06-27.pptx
@@ -3865,16 +3865,16 @@
               </a:defRPr>
             </a:pPr>
             <a:r>
-              <a:t>로드맵 문서: docs/Project_Status_and_Updated_Roadmap_2026-06-19.md</a:t>
+              <a:t>로드맵 문서: docs/Project_Status_and_Updated_Roadmap_2026-06-19.md (40% 완료, 다음 Phase 3)</a:t>
             </a:r>
             <a:br/>
             <a:r>
-              <a:t>백로그 문서: docs/Task_Prioritized_Backlog_and_Schedule_2026-06-19.md</a:t>
+              <a:t>백로그: 상세 일/주 단위 + 시각적 트래킹 (Phase 3 북마크부터)</a:t>
             </a:r>
             <a:br/>
             <a:br/>
             <a:r>
-              <a:t>이 문서를 기반으로 Phase 1부터 순차 진행을 권장합니다.</a:t>
+              <a:t>현재: Phase 0-2 ✅ | 다음: Phase 3 ⏳ | 전체: 10슬라이드 PPTX 자동 생성</a:t>
             </a:r>
           </a:p>
         </p:txBody>
@@ -4219,7 +4219,7 @@
               </a:defRPr>
             </a:pPr>
             <a:r>
-              <a:t>현재 상태</a:t>
+              <a:t>현재 상태 (2026-06-27)</a:t>
             </a:r>
           </a:p>
         </p:txBody>
@@ -4233,7 +4233,7 @@
         <p:spPr>
           <a:xfrm>
             <a:off x="457200" y="914400"/>
-            <a:ext cx="8229600" cy="3657600"/>
+            <a:ext cx="8229600" cy="365760"/>
           </a:xfrm>
           <a:prstGeom prst="rect">
             <a:avLst/>
@@ -4246,52 +4246,121 @@
           </a:bodyPr>
           <a:lstStyle/>
           <a:p>
+            <a:pPr algn="l">
+              <a:defRPr sz="1400" b="1">
+                <a:solidFill>
+                  <a:srgbClr val="1E3A5F"/>
+                </a:solidFill>
+                <a:latin typeface="Malgun Gothic"/>
+              </a:defRPr>
+            </a:pPr>
+            <a:r>
+              <a:t>전체 로드맵: [████████░░░░░░░░░░░░░░░░░░░░] ~40% 완료</a:t>
+            </a:r>
+          </a:p>
+        </p:txBody>
+      </p:sp>
+      <p:sp>
+        <p:nvSpPr>
+          <p:cNvPr id="6" name="TextBox 5"/>
+          <p:cNvSpPr txBox="1"/>
+          <p:nvPr/>
+        </p:nvSpPr>
+        <p:spPr>
+          <a:xfrm>
+            <a:off x="457200" y="1280160"/>
+            <a:ext cx="8229600" cy="365760"/>
+          </a:xfrm>
+          <a:prstGeom prst="rect">
+            <a:avLst/>
+          </a:prstGeom>
+          <a:noFill/>
+        </p:spPr>
+        <p:txBody>
+          <a:bodyPr wrap="square">
+            <a:spAutoFit/>
+          </a:bodyPr>
+          <a:lstStyle/>
+          <a:p>
+            <a:pPr algn="l">
+              <a:defRPr sz="1200" b="0">
+                <a:solidFill>
+                  <a:srgbClr val="1E293B"/>
+                </a:solidFill>
+                <a:latin typeface="Malgun Gothic"/>
+              </a:defRPr>
+            </a:pPr>
+            <a:r>
+              <a:t>Phase 0-2: ██████████ 100% ✅ | Phase 3: ░░░░░░░░░░ 0% ⏳ | Phase 4-5: ░░░░░░░░░░ 0%</a:t>
+            </a:r>
+          </a:p>
+        </p:txBody>
+      </p:sp>
+      <p:sp>
+        <p:nvSpPr>
+          <p:cNvPr id="7" name="TextBox 6"/>
+          <p:cNvSpPr txBox="1"/>
+          <p:nvPr/>
+        </p:nvSpPr>
+        <p:spPr>
+          <a:xfrm>
+            <a:off x="457200" y="1737360"/>
+            <a:ext cx="8229600" cy="2926080"/>
+          </a:xfrm>
+          <a:prstGeom prst="rect">
+            <a:avLst/>
+          </a:prstGeom>
+          <a:noFill/>
+        </p:spPr>
+        <p:txBody>
+          <a:bodyPr wrap="square">
+            <a:spAutoFit/>
+          </a:bodyPr>
+          <a:lstStyle/>
+          <a:p>
             <a:pPr>
-              <a:defRPr sz="1400">
+              <a:defRPr sz="1200">
                 <a:solidFill>
                   <a:srgbClr val="1E293B"/>
                 </a:solidFill>
               </a:defRPr>
             </a:pPr>
             <a:r>
-              <a:t>완료</a:t>
+              <a:t>완료된 주요 작업</a:t>
             </a:r>
             <a:br/>
             <a:r>
-              <a:t>• Flutter 프로젝트 초기화 및 다중 플랫폼 준비</a:t>
+              <a:t>• Phase 0: 기반 구조, 의존성, 데이터 배치, 기본 스켈레톤, 빌드 성공</a:t>
             </a:r>
             <a:br/>
             <a:r>
-              <a:t>• Hive, Provider 등 의존성 설정 완료</a:t>
+              <a:t>• Phase 1: 데이터 모델 (3개) + Hive 어댑터 + JSON 로더 (service) + 시드/초기화 완료</a:t>
             </a:r>
             <a:br/>
             <a:r>
-              <a:t>• 성경 데이터 assets/data/에 배치</a:t>
-            </a:r>
-            <a:br/>
-            <a:r>
-              <a:t>• 기본 앱 스켈레톤 (Hive init + 한국어 UI)</a:t>
-            </a:r>
-            <a:br/>
-            <a:r>
-              <a:t>• flutter analyze 클린 + Windows 빌드 성공</a:t>
+              <a:t>• Phase 2: 책 목록 (bilingual full title + 검색 + 필터 + 본문 검색), 장 그리드, 본문 뷰어 (RichText + prev/next + 홈), Provider, 디자인 개선</a:t>
             </a:r>
             <a:br/>
             <a:br/>
             <a:r>
-              <a:t>진행 중 / 미완성</a:t>
+              <a:t>당장 다음 할 일 (상세, &lt;1주 단위)</a:t>
             </a:r>
             <a:br/>
             <a:r>
-              <a:t>• 실제 성경 데이터 로딩 및 UI 미구현</a:t>
+              <a:t>1. Phase 3 Day1~2: Bookmark model + Hive box + viewer 버튼 + 목록 화면</a:t>
             </a:r>
             <a:br/>
             <a:r>
-              <a:t>• Hive 모델/어댑터 미구현</a:t>
+              <a:t>2. Phase 3 Day2~3: Highlight + note per verse (selection + save)</a:t>
             </a:r>
             <a:br/>
             <a:r>
-              <a:t>• 로드맵/백로그 문서 이제 작성 완료 (Updated 2026-06-27)</a:t>
+              <a:t>3. Phase 3 Day3~5: 본문 검색 결과 polish + 하이라이트 + 설정 화면 (글꼴/다크모드)</a:t>
+            </a:r>
+            <a:br/>
+            <a:br/>
+            <a:r>
+              <a:t>로드맵 대비 남은 것: Phase 3 사용자 기능 전체, Phase 4 고도화, Phase 5 배포</a:t>
             </a:r>
           </a:p>
         </p:txBody>
@@ -4834,13 +4903,13 @@
             <a:pPr algn="ctr">
               <a:defRPr sz="900" b="1">
                 <a:solidFill>
-                  <a:srgbClr val="0D9488"/>
+                  <a:srgbClr val="D97706"/>
                 </a:solidFill>
                 <a:latin typeface="Malgun Gothic"/>
               </a:defRPr>
             </a:pPr>
             <a:r>
-              <a:t>완료</a:t>
+              <a:t>✅ 완료</a:t>
             </a:r>
           </a:p>
         </p:txBody>
@@ -4905,7 +4974,7 @@
             <a:avLst/>
           </a:prstGeom>
           <a:solidFill>
-            <a:srgbClr val="0D9488"/>
+            <a:srgbClr val="1E3A5F"/>
           </a:solidFill>
           <a:ln>
             <a:noFill/>
@@ -5030,13 +5099,13 @@
             <a:pPr algn="ctr">
               <a:defRPr sz="900" b="1">
                 <a:solidFill>
-                  <a:srgbClr val="0D9488"/>
+                  <a:srgbClr val="D97706"/>
                 </a:solidFill>
                 <a:latin typeface="Malgun Gothic"/>
               </a:defRPr>
             </a:pPr>
             <a:r>
-              <a:t>최우선</a:t>
+              <a:t>✅ 완료</a:t>
             </a:r>
           </a:p>
         </p:txBody>
@@ -5101,7 +5170,7 @@
             <a:avLst/>
           </a:prstGeom>
           <a:solidFill>
-            <a:srgbClr val="0D9488"/>
+            <a:srgbClr val="1E3A5F"/>
           </a:solidFill>
           <a:ln>
             <a:noFill/>
@@ -5196,7 +5265,7 @@
               </a:defRPr>
             </a:pPr>
             <a:r>
-              <a:t>핵심 읽기 MVP</a:t>
+              <a:t>기본 읽기 UI</a:t>
             </a:r>
           </a:p>
         </p:txBody>
@@ -5226,13 +5295,13 @@
             <a:pPr algn="ctr">
               <a:defRPr sz="900" b="1">
                 <a:solidFill>
-                  <a:srgbClr val="0D9488"/>
+                  <a:srgbClr val="D97706"/>
                 </a:solidFill>
                 <a:latin typeface="Malgun Gothic"/>
               </a:defRPr>
             </a:pPr>
             <a:r>
-              <a:t>MVP</a:t>
+              <a:t>✅ 완료</a:t>
             </a:r>
           </a:p>
         </p:txBody>
@@ -5297,7 +5366,7 @@
             <a:avLst/>
           </a:prstGeom>
           <a:solidFill>
-            <a:srgbClr val="D97706"/>
+            <a:srgbClr val="0D9488"/>
           </a:solidFill>
           <a:ln>
             <a:noFill/>
@@ -5428,7 +5497,7 @@
               </a:defRPr>
             </a:pPr>
             <a:r>
-              <a:t>중요</a:t>
+              <a:t>⏳ 다음</a:t>
             </a:r>
           </a:p>
         </p:txBody>
@@ -5624,7 +5693,7 @@
               </a:defRPr>
             </a:pPr>
             <a:r>
-              <a:t>품질</a:t>
+              <a:t>⏳ 미완</a:t>
             </a:r>
           </a:p>
         </p:txBody>
@@ -5689,7 +5758,7 @@
             <a:avLst/>
           </a:prstGeom>
           <a:solidFill>
-            <a:srgbClr val="1E3A5F"/>
+            <a:srgbClr val="D97706"/>
           </a:solidFill>
           <a:ln>
             <a:noFill/>
@@ -5820,7 +5889,7 @@
               </a:defRPr>
             </a:pPr>
             <a:r>
-              <a:t>릴리스</a:t>
+              <a:t>⏳ 미완</a:t>
             </a:r>
           </a:p>
         </p:txBody>
@@ -7919,7 +7988,7 @@
               </a:defRPr>
             </a:pPr>
             <a:r>
-              <a:t>1. Phase 1: 데이터 모델 정의 (BibleBook, Chapter, Verse)</a:t>
+              <a:t>1. Phase 3 Day1~2: Bookmark model + Hive box + viewer 버튼 + 목록 (북마크)</a:t>
             </a:r>
           </a:p>
         </p:txBody>
@@ -8000,7 +8069,7 @@
               </a:defRPr>
             </a:pPr>
             <a:r>
-              <a:t>2. Hive 어댑터 생성 및 build_runner 실행</a:t>
+              <a:t>2. Phase 3 Day2~3: Highlight + note per verse (selection + save)</a:t>
             </a:r>
           </a:p>
         </p:txBody>
@@ -8081,7 +8150,7 @@
               </a:defRPr>
             </a:pPr>
             <a:r>
-              <a:t>3. JSON 파서 + 앱 시작 시 데이터 로드 구현</a:t>
+              <a:t>3. Phase 3 Day3~5: 본문 검색 결과 polish + 하이라이트 + 설정 (글꼴/다크)</a:t>
             </a:r>
           </a:p>
         </p:txBody>
@@ -8162,7 +8231,7 @@
               </a:defRPr>
             </a:pPr>
             <a:r>
-              <a:t>4. Phase 2: 책 목록 + 장 선택 + 본문 뷰어 UI</a:t>
+              <a:t>4. Phase 4 Day1: Theme provider + 다크모드</a:t>
             </a:r>
           </a:p>
         </p:txBody>
@@ -8243,7 +8312,7 @@
               </a:defRPr>
             </a:pPr>
             <a:r>
-              <a:t>5. 네비게이션 및 현재 위치 저장</a:t>
+              <a:t>5. Phase 4 Day3~5: 반응형 LayoutBuilder + 접근성</a:t>
             </a:r>
           </a:p>
         </p:txBody>
@@ -8324,7 +8393,7 @@
               </a:defRPr>
             </a:pPr>
             <a:r>
-              <a:t>6. 북마크 / 검색 기능 (Hive 기반)</a:t>
+              <a:t>6. Phase 5 Day1~2: Android build + 테스트</a:t>
             </a:r>
           </a:p>
         </p:txBody>
@@ -8405,7 +8474,7 @@
               </a:defRPr>
             </a:pPr>
             <a:r>
-              <a:t>7. 설정 화면 및 UI 고도화</a:t>
+              <a:t>7. Phase 5 Day2~4: iOS build + Xcode 테스트</a:t>
             </a:r>
           </a:p>
         </p:txBody>
@@ -8486,7 +8555,7 @@
               </a:defRPr>
             </a:pPr>
             <a:r>
-              <a:t>8. Android/iOS 빌드 검증 및 릴리스 준비</a:t>
+              <a:t>8. Phase 5 Day4~7: Web PWA + 릴리스 + 스토어 준비</a:t>
             </a:r>
           </a:p>
         </p:txBody>

</xml_diff>

<commit_message>
Add visual progress bar shapes and clearer next tasks to roadmap-pptx output 2026-06-27
</commit_message>
<xml_diff>
--- a/docs/roadmap-pptx/Korean_Bible_App_Roadmap_및_작업제안_2026-06-27.pptx
+++ b/docs/roadmap-pptx/Korean_Bible_App_Roadmap_및_작업제안_2026-06-27.pptx
@@ -4233,7 +4233,7 @@
         <p:spPr>
           <a:xfrm>
             <a:off x="457200" y="914400"/>
-            <a:ext cx="8229600" cy="365760"/>
+            <a:ext cx="8229600" cy="320040"/>
           </a:xfrm>
           <a:prstGeom prst="rect">
             <a:avLst/>
@@ -4247,7 +4247,7 @@
           <a:lstStyle/>
           <a:p>
             <a:pPr algn="l">
-              <a:defRPr sz="1400" b="1">
+              <a:defRPr sz="1300" b="1">
                 <a:solidFill>
                   <a:srgbClr val="1E3A5F"/>
                 </a:solidFill>
@@ -4255,21 +4255,107 @@
               </a:defRPr>
             </a:pPr>
             <a:r>
-              <a:t>전체 로드맵: [████████░░░░░░░░░░░░░░░░░░░░] ~40% 완료</a:t>
-            </a:r>
-          </a:p>
-        </p:txBody>
-      </p:sp>
-      <p:sp>
-        <p:nvSpPr>
-          <p:cNvPr id="6" name="TextBox 5"/>
+              <a:t>전체 로드맵 진행률: ~40% 완료 (Phase 0-2 ✅ | Phase 3+ ⏳)</a:t>
+            </a:r>
+          </a:p>
+        </p:txBody>
+      </p:sp>
+      <p:sp>
+        <p:nvSpPr>
+          <p:cNvPr id="6" name="Rectangle 5"/>
+          <p:cNvSpPr/>
+          <p:nvPr/>
+        </p:nvSpPr>
+        <p:spPr>
+          <a:xfrm>
+            <a:off x="457200" y="1280160"/>
+            <a:ext cx="8229600" cy="228600"/>
+          </a:xfrm>
+          <a:prstGeom prst="rect">
+            <a:avLst/>
+          </a:prstGeom>
+          <a:solidFill>
+            <a:srgbClr val="E2E8F0"/>
+          </a:solidFill>
+          <a:ln>
+            <a:noFill/>
+          </a:ln>
+        </p:spPr>
+        <p:style>
+          <a:lnRef idx="1">
+            <a:schemeClr val="accent1"/>
+          </a:lnRef>
+          <a:fillRef idx="3">
+            <a:schemeClr val="accent1"/>
+          </a:fillRef>
+          <a:effectRef idx="2">
+            <a:schemeClr val="accent1"/>
+          </a:effectRef>
+          <a:fontRef idx="minor">
+            <a:schemeClr val="lt1"/>
+          </a:fontRef>
+        </p:style>
+        <p:txBody>
+          <a:bodyPr rtlCol="0" anchor="ctr"/>
+          <a:lstStyle/>
+          <a:p>
+            <a:pPr algn="ctr"/>
+          </a:p>
+        </p:txBody>
+      </p:sp>
+      <p:sp>
+        <p:nvSpPr>
+          <p:cNvPr id="7" name="Rectangle 6"/>
+          <p:cNvSpPr/>
+          <p:nvPr/>
+        </p:nvSpPr>
+        <p:spPr>
+          <a:xfrm>
+            <a:off x="457200" y="1280160"/>
+            <a:ext cx="3291840" cy="228600"/>
+          </a:xfrm>
+          <a:prstGeom prst="rect">
+            <a:avLst/>
+          </a:prstGeom>
+          <a:solidFill>
+            <a:srgbClr val="0D9488"/>
+          </a:solidFill>
+          <a:ln>
+            <a:noFill/>
+          </a:ln>
+        </p:spPr>
+        <p:style>
+          <a:lnRef idx="1">
+            <a:schemeClr val="accent1"/>
+          </a:lnRef>
+          <a:fillRef idx="3">
+            <a:schemeClr val="accent1"/>
+          </a:fillRef>
+          <a:effectRef idx="2">
+            <a:schemeClr val="accent1"/>
+          </a:effectRef>
+          <a:fontRef idx="minor">
+            <a:schemeClr val="lt1"/>
+          </a:fontRef>
+        </p:style>
+        <p:txBody>
+          <a:bodyPr rtlCol="0" anchor="ctr"/>
+          <a:lstStyle/>
+          <a:p>
+            <a:pPr algn="ctr"/>
+          </a:p>
+        </p:txBody>
+      </p:sp>
+      <p:sp>
+        <p:nvSpPr>
+          <p:cNvPr id="8" name="TextBox 7"/>
           <p:cNvSpPr txBox="1"/>
           <p:nvPr/>
         </p:nvSpPr>
         <p:spPr>
           <a:xfrm>
-            <a:off x="457200" y="1280160"/>
-            <a:ext cx="8229600" cy="365760"/>
+            <a:off x="457200" y="1554480"/>
+            <a:ext cx="8229600" cy="274320"/>
           </a:xfrm>
           <a:prstGeom prst="rect">
             <a:avLst/>
@@ -4283,7 +4369,7 @@
           <a:lstStyle/>
           <a:p>
             <a:pPr algn="l">
-              <a:defRPr sz="1200" b="0">
+              <a:defRPr sz="1100" b="0">
                 <a:solidFill>
                   <a:srgbClr val="1E293B"/>
                 </a:solidFill>
@@ -4291,14 +4377,14 @@
               </a:defRPr>
             </a:pPr>
             <a:r>
-              <a:t>Phase 0-2: ██████████ 100% ✅ | Phase 3: ░░░░░░░░░░ 0% ⏳ | Phase 4-5: ░░░░░░░░░░ 0%</a:t>
-            </a:r>
-          </a:p>
-        </p:txBody>
-      </p:sp>
-      <p:sp>
-        <p:nvSpPr>
-          <p:cNvPr id="7" name="TextBox 6"/>
+              <a:t>Phase별: 0-2 ████ 100% | 3 ░░░░ 0% | 4-5 ░░░░ 0%</a:t>
+            </a:r>
+          </a:p>
+        </p:txBody>
+      </p:sp>
+      <p:sp>
+        <p:nvSpPr>
+          <p:cNvPr id="9" name="TextBox 8"/>
           <p:cNvSpPr txBox="1"/>
           <p:nvPr/>
         </p:nvSpPr>

</xml_diff>

<commit_message>
Final roadmap-pptx with explicit current status, detailed next tasks, visual clarity 2026-06-27
</commit_message>
<xml_diff>
--- a/docs/roadmap-pptx/Korean_Bible_App_Roadmap_및_작업제안_2026-06-27.pptx
+++ b/docs/roadmap-pptx/Korean_Bible_App_Roadmap_및_작업제안_2026-06-27.pptx
@@ -4405,48 +4405,48 @@
           <a:lstStyle/>
           <a:p>
             <a:pPr>
-              <a:defRPr sz="1200">
+              <a:defRPr sz="1100">
                 <a:solidFill>
                   <a:srgbClr val="1E293B"/>
                 </a:solidFill>
               </a:defRPr>
             </a:pPr>
             <a:r>
-              <a:t>완료된 주요 작업</a:t>
+              <a:t>✅ 완료된 상태 (전체 로드맵 대비 ~40%)</a:t>
             </a:r>
             <a:br/>
             <a:r>
-              <a:t>• Phase 0: 기반 구조, 의존성, 데이터 배치, 기본 스켈레톤, 빌드 성공</a:t>
+              <a:t>• Phase 0: 기반, 의존성, 데이터, 스켈레톤, 빌드 ✅</a:t>
             </a:r>
             <a:br/>
             <a:r>
-              <a:t>• Phase 1: 데이터 모델 (3개) + Hive 어댑터 + JSON 로더 (service) + 시드/초기화 완료</a:t>
+              <a:t>• Phase 1: 모델 3개 + 어댑터 + JSON 로더 + 시드 ✅</a:t>
             </a:r>
             <a:br/>
             <a:r>
-              <a:t>• Phase 2: 책 목록 (bilingual full title + 검색 + 필터 + 본문 검색), 장 그리드, 본문 뷰어 (RichText + prev/next + 홈), Provider, 디자인 개선</a:t>
+              <a:t>• Phase 2: 책목록(bilingual+검색+필터+본문검색), 장그리드, 뷰어(Rich+prev/next+홈), Provider, 디자인 ✅</a:t>
             </a:r>
             <a:br/>
             <a:br/>
             <a:r>
-              <a:t>당장 다음 할 일 (상세, &lt;1주 단위)</a:t>
+              <a:t>⏳ 당장 다음 할 일 (상세 범위, &lt;1주, Top 3)</a:t>
             </a:r>
             <a:br/>
             <a:r>
-              <a:t>1. Phase 3 Day1~2: Bookmark model + Hive box + viewer 버튼 + 목록 화면</a:t>
+              <a:t>1. Phase 3 D1-2: 북마크 - model+Hive box + viewer 버튼 + 목록 화면 구현</a:t>
             </a:r>
             <a:br/>
             <a:r>
-              <a:t>2. Phase 3 Day2~3: Highlight + note per verse (selection + save)</a:t>
+              <a:t>2. Phase 3 D2-3: 하이라이트/메모 - verse selection + Hive 저장 + 표시</a:t>
             </a:r>
             <a:br/>
             <a:r>
-              <a:t>3. Phase 3 Day3~5: 본문 검색 결과 polish + 하이라이트 + 설정 화면 (글꼴/다크모드)</a:t>
+              <a:t>3. Phase 3 D3-5: 검색 polish + 설정 - 결과 하이라이트 + 글꼴/다크 토글 화면</a:t>
             </a:r>
             <a:br/>
             <a:br/>
             <a:r>
-              <a:t>로드맵 대비 남은 것: Phase 3 사용자 기능 전체, Phase 4 고도화, Phase 5 배포</a:t>
+              <a:t>남은 것: Phase 3 (사용자기능), Phase 4 (고도화), Phase 5 (배포) - 백로그에 일/주 단위 상세</a:t>
             </a:r>
           </a:p>
         </p:txBody>

</xml_diff>